<commit_message>
Expandend informative and normative sections
</commit_message>
<xml_diff>
--- a/website/static/img/communication-layer/powerpoint_img_source.pptx
+++ b/website/static/img/communication-layer/powerpoint_img_source.pptx
@@ -198,7 +198,7 @@
           <a:p>
             <a:fld id="{E7EFD5C7-1DE8-4077-AAC8-BF5347CF05DC}" type="datetimeFigureOut">
               <a:rPr lang="nl-NL" smtClean="0"/>
-              <a:t>20-11-2025</a:t>
+              <a:t>25-11-2025</a:t>
             </a:fld>
             <a:endParaRPr lang="nl-NL"/>
           </a:p>
@@ -699,7 +699,7 @@
           <a:p>
             <a:fld id="{345CDBC5-1A53-47AD-8124-4290C45B6D9D}" type="datetimeFigureOut">
               <a:rPr lang="nl-NL" smtClean="0"/>
-              <a:t>20-11-2025</a:t>
+              <a:t>25-11-2025</a:t>
             </a:fld>
             <a:endParaRPr lang="nl-NL"/>
           </a:p>
@@ -899,7 +899,7 @@
           <a:p>
             <a:fld id="{345CDBC5-1A53-47AD-8124-4290C45B6D9D}" type="datetimeFigureOut">
               <a:rPr lang="nl-NL" smtClean="0"/>
-              <a:t>20-11-2025</a:t>
+              <a:t>25-11-2025</a:t>
             </a:fld>
             <a:endParaRPr lang="nl-NL"/>
           </a:p>
@@ -1109,7 +1109,7 @@
           <a:p>
             <a:fld id="{345CDBC5-1A53-47AD-8124-4290C45B6D9D}" type="datetimeFigureOut">
               <a:rPr lang="nl-NL" smtClean="0"/>
-              <a:t>20-11-2025</a:t>
+              <a:t>25-11-2025</a:t>
             </a:fld>
             <a:endParaRPr lang="nl-NL"/>
           </a:p>
@@ -1651,7 +1651,7 @@
           <a:p>
             <a:fld id="{345CDBC5-1A53-47AD-8124-4290C45B6D9D}" type="datetimeFigureOut">
               <a:rPr lang="nl-NL" smtClean="0"/>
-              <a:t>20-11-2025</a:t>
+              <a:t>25-11-2025</a:t>
             </a:fld>
             <a:endParaRPr lang="nl-NL"/>
           </a:p>
@@ -1927,7 +1927,7 @@
           <a:p>
             <a:fld id="{345CDBC5-1A53-47AD-8124-4290C45B6D9D}" type="datetimeFigureOut">
               <a:rPr lang="nl-NL" smtClean="0"/>
-              <a:t>20-11-2025</a:t>
+              <a:t>25-11-2025</a:t>
             </a:fld>
             <a:endParaRPr lang="nl-NL"/>
           </a:p>
@@ -2195,7 +2195,7 @@
           <a:p>
             <a:fld id="{345CDBC5-1A53-47AD-8124-4290C45B6D9D}" type="datetimeFigureOut">
               <a:rPr lang="nl-NL" smtClean="0"/>
-              <a:t>20-11-2025</a:t>
+              <a:t>25-11-2025</a:t>
             </a:fld>
             <a:endParaRPr lang="nl-NL"/>
           </a:p>
@@ -2610,7 +2610,7 @@
           <a:p>
             <a:fld id="{345CDBC5-1A53-47AD-8124-4290C45B6D9D}" type="datetimeFigureOut">
               <a:rPr lang="nl-NL" smtClean="0"/>
-              <a:t>20-11-2025</a:t>
+              <a:t>25-11-2025</a:t>
             </a:fld>
             <a:endParaRPr lang="nl-NL"/>
           </a:p>
@@ -2752,7 +2752,7 @@
           <a:p>
             <a:fld id="{345CDBC5-1A53-47AD-8124-4290C45B6D9D}" type="datetimeFigureOut">
               <a:rPr lang="nl-NL" smtClean="0"/>
-              <a:t>20-11-2025</a:t>
+              <a:t>25-11-2025</a:t>
             </a:fld>
             <a:endParaRPr lang="nl-NL"/>
           </a:p>
@@ -2865,7 +2865,7 @@
           <a:p>
             <a:fld id="{345CDBC5-1A53-47AD-8124-4290C45B6D9D}" type="datetimeFigureOut">
               <a:rPr lang="nl-NL" smtClean="0"/>
-              <a:t>20-11-2025</a:t>
+              <a:t>25-11-2025</a:t>
             </a:fld>
             <a:endParaRPr lang="nl-NL"/>
           </a:p>
@@ -3178,7 +3178,7 @@
           <a:p>
             <a:fld id="{345CDBC5-1A53-47AD-8124-4290C45B6D9D}" type="datetimeFigureOut">
               <a:rPr lang="nl-NL" smtClean="0"/>
-              <a:t>20-11-2025</a:t>
+              <a:t>25-11-2025</a:t>
             </a:fld>
             <a:endParaRPr lang="nl-NL"/>
           </a:p>
@@ -3467,7 +3467,7 @@
           <a:p>
             <a:fld id="{345CDBC5-1A53-47AD-8124-4290C45B6D9D}" type="datetimeFigureOut">
               <a:rPr lang="nl-NL" smtClean="0"/>
-              <a:t>20-11-2025</a:t>
+              <a:t>25-11-2025</a:t>
             </a:fld>
             <a:endParaRPr lang="nl-NL"/>
           </a:p>
@@ -3710,7 +3710,7 @@
           <a:p>
             <a:fld id="{345CDBC5-1A53-47AD-8124-4290C45B6D9D}" type="datetimeFigureOut">
               <a:rPr lang="nl-NL" smtClean="0"/>
-              <a:t>20-11-2025</a:t>
+              <a:t>25-11-2025</a:t>
             </a:fld>
             <a:endParaRPr lang="nl-NL"/>
           </a:p>
@@ -7565,7 +7565,7 @@
             <a:pPr algn="ctr"/>
             <a:r>
               <a:rPr lang="en-US"/>
-              <a:t>S2 pairing server (</a:t>
+              <a:t>WAN S2 pairing server (</a:t>
             </a:r>
             <a:r>
               <a:rPr lang="en-US" dirty="0"/>
@@ -7625,7 +7625,7 @@
             <a:pPr algn="ctr"/>
             <a:r>
               <a:rPr lang="en-US" dirty="0"/>
-              <a:t>S2 pairing server (optional)</a:t>
+              <a:t>WAN S2 pairing server (optional)</a:t>
             </a:r>
             <a:endParaRPr lang="nl-NL" dirty="0"/>
           </a:p>

</xml_diff>

<commit_message>
Improved overview image for pairing
</commit_message>
<xml_diff>
--- a/website/static/img/communication-layer/powerpoint_img_source.pptx
+++ b/website/static/img/communication-layer/powerpoint_img_source.pptx
@@ -208,7 +208,7 @@
           <a:p>
             <a:fld id="{E7EFD5C7-1DE8-4077-AAC8-BF5347CF05DC}" type="datetimeFigureOut">
               <a:rPr lang="nl-NL" smtClean="0"/>
-              <a:t>22-6-2026</a:t>
+              <a:t>9-7-2026</a:t>
             </a:fld>
             <a:endParaRPr lang="nl-NL"/>
           </a:p>
@@ -644,6 +644,90 @@
 </p:notes>
 </file>
 
+<file path=ppt/notesSlides/notesSlide3.xml><?xml version="1.0" encoding="utf-8"?>
+<p:notes xmlns:a="http://schemas.openxmlformats.org/drawingml/2006/main" xmlns:r="http://schemas.openxmlformats.org/officeDocument/2006/relationships" xmlns:p="http://schemas.openxmlformats.org/presentationml/2006/main">
+  <p:cSld>
+    <p:spTree>
+      <p:nvGrpSpPr>
+        <p:cNvPr id="1" name=""/>
+        <p:cNvGrpSpPr/>
+        <p:nvPr/>
+      </p:nvGrpSpPr>
+      <p:grpSpPr>
+        <a:xfrm>
+          <a:off x="0" y="0"/>
+          <a:ext cx="0" cy="0"/>
+          <a:chOff x="0" y="0"/>
+          <a:chExt cx="0" cy="0"/>
+        </a:xfrm>
+      </p:grpSpPr>
+      <p:sp>
+        <p:nvSpPr>
+          <p:cNvPr id="2" name="Slide Image Placeholder 1"/>
+          <p:cNvSpPr>
+            <a:spLocks noGrp="1" noRot="1" noChangeAspect="1"/>
+          </p:cNvSpPr>
+          <p:nvPr>
+            <p:ph type="sldImg"/>
+          </p:nvPr>
+        </p:nvSpPr>
+        <p:spPr/>
+      </p:sp>
+      <p:sp>
+        <p:nvSpPr>
+          <p:cNvPr id="3" name="Notes Placeholder 2"/>
+          <p:cNvSpPr>
+            <a:spLocks noGrp="1"/>
+          </p:cNvSpPr>
+          <p:nvPr>
+            <p:ph type="body" idx="1"/>
+          </p:nvPr>
+        </p:nvSpPr>
+        <p:spPr/>
+        <p:txBody>
+          <a:bodyPr/>
+          <a:lstStyle/>
+          <a:p>
+            <a:endParaRPr lang="en-GB" dirty="0"/>
+          </a:p>
+        </p:txBody>
+      </p:sp>
+      <p:sp>
+        <p:nvSpPr>
+          <p:cNvPr id="4" name="Slide Number Placeholder 3"/>
+          <p:cNvSpPr>
+            <a:spLocks noGrp="1"/>
+          </p:cNvSpPr>
+          <p:nvPr>
+            <p:ph type="sldNum" sz="quarter" idx="5"/>
+          </p:nvPr>
+        </p:nvSpPr>
+        <p:spPr/>
+        <p:txBody>
+          <a:bodyPr/>
+          <a:lstStyle/>
+          <a:p>
+            <a:fld id="{366554AD-CA37-459A-AD41-9A8696F14505}" type="slidenum">
+              <a:rPr lang="nl-NL" smtClean="0"/>
+              <a:t>6</a:t>
+            </a:fld>
+            <a:endParaRPr lang="nl-NL"/>
+          </a:p>
+        </p:txBody>
+      </p:sp>
+    </p:spTree>
+    <p:extLst>
+      <p:ext uri="{BB962C8B-B14F-4D97-AF65-F5344CB8AC3E}">
+        <p14:creationId xmlns:p14="http://schemas.microsoft.com/office/powerpoint/2010/main" val="2606583507"/>
+      </p:ext>
+    </p:extLst>
+  </p:cSld>
+  <p:clrMapOvr>
+    <a:masterClrMapping/>
+  </p:clrMapOvr>
+</p:notes>
+</file>
+
 <file path=ppt/slideLayouts/slideLayout1.xml><?xml version="1.0" encoding="utf-8"?>
 <p:sldLayout xmlns:a="http://schemas.openxmlformats.org/drawingml/2006/main" xmlns:r="http://schemas.openxmlformats.org/officeDocument/2006/relationships" xmlns:p="http://schemas.openxmlformats.org/presentationml/2006/main" type="title" preserve="1">
   <p:cSld name="Title Slide">
@@ -793,7 +877,7 @@
           <a:p>
             <a:fld id="{345CDBC5-1A53-47AD-8124-4290C45B6D9D}" type="datetimeFigureOut">
               <a:rPr lang="nl-NL" smtClean="0"/>
-              <a:t>22-6-2026</a:t>
+              <a:t>9-7-2026</a:t>
             </a:fld>
             <a:endParaRPr lang="nl-NL"/>
           </a:p>
@@ -993,7 +1077,7 @@
           <a:p>
             <a:fld id="{345CDBC5-1A53-47AD-8124-4290C45B6D9D}" type="datetimeFigureOut">
               <a:rPr lang="nl-NL" smtClean="0"/>
-              <a:t>22-6-2026</a:t>
+              <a:t>9-7-2026</a:t>
             </a:fld>
             <a:endParaRPr lang="nl-NL"/>
           </a:p>
@@ -1203,7 +1287,7 @@
           <a:p>
             <a:fld id="{345CDBC5-1A53-47AD-8124-4290C45B6D9D}" type="datetimeFigureOut">
               <a:rPr lang="nl-NL" smtClean="0"/>
-              <a:t>22-6-2026</a:t>
+              <a:t>9-7-2026</a:t>
             </a:fld>
             <a:endParaRPr lang="nl-NL"/>
           </a:p>
@@ -1745,7 +1829,7 @@
           <a:p>
             <a:fld id="{345CDBC5-1A53-47AD-8124-4290C45B6D9D}" type="datetimeFigureOut">
               <a:rPr lang="nl-NL" smtClean="0"/>
-              <a:t>22-6-2026</a:t>
+              <a:t>9-7-2026</a:t>
             </a:fld>
             <a:endParaRPr lang="nl-NL"/>
           </a:p>
@@ -2021,7 +2105,7 @@
           <a:p>
             <a:fld id="{345CDBC5-1A53-47AD-8124-4290C45B6D9D}" type="datetimeFigureOut">
               <a:rPr lang="nl-NL" smtClean="0"/>
-              <a:t>22-6-2026</a:t>
+              <a:t>9-7-2026</a:t>
             </a:fld>
             <a:endParaRPr lang="nl-NL"/>
           </a:p>
@@ -2289,7 +2373,7 @@
           <a:p>
             <a:fld id="{345CDBC5-1A53-47AD-8124-4290C45B6D9D}" type="datetimeFigureOut">
               <a:rPr lang="nl-NL" smtClean="0"/>
-              <a:t>22-6-2026</a:t>
+              <a:t>9-7-2026</a:t>
             </a:fld>
             <a:endParaRPr lang="nl-NL"/>
           </a:p>
@@ -2704,7 +2788,7 @@
           <a:p>
             <a:fld id="{345CDBC5-1A53-47AD-8124-4290C45B6D9D}" type="datetimeFigureOut">
               <a:rPr lang="nl-NL" smtClean="0"/>
-              <a:t>22-6-2026</a:t>
+              <a:t>9-7-2026</a:t>
             </a:fld>
             <a:endParaRPr lang="nl-NL"/>
           </a:p>
@@ -2846,7 +2930,7 @@
           <a:p>
             <a:fld id="{345CDBC5-1A53-47AD-8124-4290C45B6D9D}" type="datetimeFigureOut">
               <a:rPr lang="nl-NL" smtClean="0"/>
-              <a:t>22-6-2026</a:t>
+              <a:t>9-7-2026</a:t>
             </a:fld>
             <a:endParaRPr lang="nl-NL"/>
           </a:p>
@@ -2959,7 +3043,7 @@
           <a:p>
             <a:fld id="{345CDBC5-1A53-47AD-8124-4290C45B6D9D}" type="datetimeFigureOut">
               <a:rPr lang="nl-NL" smtClean="0"/>
-              <a:t>22-6-2026</a:t>
+              <a:t>9-7-2026</a:t>
             </a:fld>
             <a:endParaRPr lang="nl-NL"/>
           </a:p>
@@ -3272,7 +3356,7 @@
           <a:p>
             <a:fld id="{345CDBC5-1A53-47AD-8124-4290C45B6D9D}" type="datetimeFigureOut">
               <a:rPr lang="nl-NL" smtClean="0"/>
-              <a:t>22-6-2026</a:t>
+              <a:t>9-7-2026</a:t>
             </a:fld>
             <a:endParaRPr lang="nl-NL"/>
           </a:p>
@@ -3561,7 +3645,7 @@
           <a:p>
             <a:fld id="{345CDBC5-1A53-47AD-8124-4290C45B6D9D}" type="datetimeFigureOut">
               <a:rPr lang="nl-NL" smtClean="0"/>
-              <a:t>22-6-2026</a:t>
+              <a:t>9-7-2026</a:t>
             </a:fld>
             <a:endParaRPr lang="nl-NL"/>
           </a:p>
@@ -3804,7 +3888,7 @@
           <a:p>
             <a:fld id="{345CDBC5-1A53-47AD-8124-4290C45B6D9D}" type="datetimeFigureOut">
               <a:rPr lang="nl-NL" smtClean="0"/>
-              <a:t>22-6-2026</a:t>
+              <a:t>9-7-2026</a:t>
             </a:fld>
             <a:endParaRPr lang="nl-NL"/>
           </a:p>
@@ -13994,13 +14078,13 @@
   <p:clrMapOvr>
     <a:masterClrMapping/>
   </p:clrMapOvr>
-  <mc:AlternateContent xmlns:mc="http://schemas.openxmlformats.org/markup-compatibility/2006">
-    <mc:Choice xmlns:p14="http://schemas.microsoft.com/office/powerpoint/2010/main" Requires="p14">
+  <mc:AlternateContent xmlns:mc="http://schemas.openxmlformats.org/markup-compatibility/2006" xmlns:p14="http://schemas.microsoft.com/office/powerpoint/2010/main">
+    <mc:Choice Requires="p14">
       <p:transition spd="med" p14:dur="700">
         <p:fade/>
       </p:transition>
     </mc:Choice>
-    <mc:Fallback>
+    <mc:Fallback xmlns="">
       <p:transition spd="med">
         <p:fade/>
       </p:transition>
@@ -17614,13 +17698,13 @@
   <p:clrMapOvr>
     <a:masterClrMapping/>
   </p:clrMapOvr>
-  <mc:AlternateContent xmlns:mc="http://schemas.openxmlformats.org/markup-compatibility/2006">
-    <mc:Choice xmlns:p14="http://schemas.microsoft.com/office/powerpoint/2010/main" Requires="p14">
+  <mc:AlternateContent xmlns:mc="http://schemas.openxmlformats.org/markup-compatibility/2006" xmlns:p14="http://schemas.microsoft.com/office/powerpoint/2010/main">
+    <mc:Choice Requires="p14">
       <p:transition spd="med" p14:dur="700">
         <p:fade/>
       </p:transition>
     </mc:Choice>
-    <mc:Fallback>
+    <mc:Fallback xmlns="">
       <p:transition spd="med">
         <p:fade/>
       </p:transition>
@@ -19748,7 +19832,7 @@
             <a:pPr algn="ctr"/>
             <a:r>
               <a:rPr lang="en-US" dirty="0"/>
-              <a:t>S2 application</a:t>
+              <a:t>S2 Endpoint</a:t>
             </a:r>
             <a:endParaRPr lang="nl-NL" dirty="0"/>
           </a:p>
@@ -19804,7 +19888,7 @@
             <a:pPr algn="ctr"/>
             <a:r>
               <a:rPr lang="en-US" dirty="0"/>
-              <a:t>S2 application</a:t>
+              <a:t>S2 Endpoint</a:t>
             </a:r>
             <a:endParaRPr lang="nl-NL" dirty="0"/>
           </a:p>
@@ -19860,7 +19944,7 @@
             <a:pPr algn="ctr"/>
             <a:r>
               <a:rPr lang="en-US" dirty="0"/>
-              <a:t>Pairing server</a:t>
+              <a:t>Pairing Server</a:t>
             </a:r>
             <a:endParaRPr lang="nl-NL" dirty="0"/>
           </a:p>
@@ -20028,7 +20112,7 @@
             <a:pPr algn="ctr"/>
             <a:r>
               <a:rPr lang="en-US" dirty="0"/>
-              <a:t>Pairing server</a:t>
+              <a:t>Pairing Server</a:t>
             </a:r>
             <a:endParaRPr lang="nl-NL" dirty="0"/>
           </a:p>
@@ -20084,7 +20168,7 @@
             <a:pPr algn="ctr"/>
             <a:r>
               <a:rPr lang="en-US" dirty="0"/>
-              <a:t>S2 application</a:t>
+              <a:t>S2 Endpoint</a:t>
             </a:r>
             <a:endParaRPr lang="nl-NL" dirty="0"/>
           </a:p>
@@ -20152,7 +20236,7 @@
             <a:pPr algn="ctr"/>
             <a:r>
               <a:rPr lang="en-US" dirty="0"/>
-              <a:t>Pairing server</a:t>
+              <a:t>Pairing Server</a:t>
             </a:r>
             <a:endParaRPr lang="nl-NL" dirty="0"/>
           </a:p>
@@ -20264,7 +20348,7 @@
             <a:pPr algn="ctr"/>
             <a:r>
               <a:rPr lang="en-US" dirty="0"/>
-              <a:t>S2 RM application</a:t>
+              <a:t>S2 RM-only Endpoint</a:t>
             </a:r>
             <a:endParaRPr lang="nl-NL" dirty="0"/>
           </a:p>
@@ -20290,12 +20374,24 @@
           <a:prstGeom prst="roundRect">
             <a:avLst/>
           </a:prstGeom>
-          <a:solidFill>
-            <a:schemeClr val="accent1">
-              <a:lumMod val="60000"/>
-              <a:lumOff val="40000"/>
-            </a:schemeClr>
-          </a:solidFill>
+          <a:gradFill flip="none" rotWithShape="1">
+            <a:gsLst>
+              <a:gs pos="29000">
+                <a:schemeClr val="accent3">
+                  <a:lumMod val="60000"/>
+                  <a:lumOff val="40000"/>
+                </a:schemeClr>
+              </a:gs>
+              <a:gs pos="100000">
+                <a:schemeClr val="accent1">
+                  <a:lumMod val="60000"/>
+                  <a:lumOff val="40000"/>
+                </a:schemeClr>
+              </a:gs>
+            </a:gsLst>
+            <a:lin ang="5400000" scaled="1"/>
+            <a:tileRect/>
+          </a:gradFill>
         </p:spPr>
         <p:style>
           <a:lnRef idx="2">
@@ -20319,8 +20415,12 @@
           <a:p>
             <a:pPr algn="ctr"/>
             <a:r>
+              <a:rPr lang="en-US"/>
+              <a:t>Pairing </a:t>
+            </a:r>
+            <a:r>
               <a:rPr lang="en-US" dirty="0"/>
-              <a:t>Pairing Client</a:t>
+              <a:t>Client</a:t>
             </a:r>
             <a:endParaRPr lang="nl-NL" dirty="0"/>
           </a:p>
@@ -20531,8 +20631,8 @@
         </p:nvSpPr>
         <p:spPr>
           <a:xfrm>
-            <a:off x="6490881" y="2778520"/>
-            <a:ext cx="1921688" cy="831850"/>
+            <a:off x="6436500" y="2778520"/>
+            <a:ext cx="2028050" cy="831850"/>
           </a:xfrm>
           <a:prstGeom prst="roundRect">
             <a:avLst/>
@@ -20587,8 +20687,8 @@
         </p:nvSpPr>
         <p:spPr>
           <a:xfrm>
-            <a:off x="1385888" y="2771774"/>
-            <a:ext cx="1809750" cy="831850"/>
+            <a:off x="1263650" y="2772854"/>
+            <a:ext cx="2025650" cy="831850"/>
           </a:xfrm>
           <a:prstGeom prst="roundRect">
             <a:avLst/>
@@ -20679,7 +20779,7 @@
             <a:pPr algn="ctr"/>
             <a:r>
               <a:rPr lang="en-US" dirty="0"/>
-              <a:t>Pairing server</a:t>
+              <a:t>Pairing Server</a:t>
             </a:r>
             <a:endParaRPr lang="nl-NL" dirty="0"/>
           </a:p>
@@ -20735,7 +20835,7 @@
             <a:pPr algn="ctr"/>
             <a:r>
               <a:rPr lang="en-US" dirty="0"/>
-              <a:t>Pairing server</a:t>
+              <a:t>Pairing Server</a:t>
             </a:r>
             <a:endParaRPr lang="nl-NL" dirty="0"/>
           </a:p>
@@ -20897,9 +20997,9 @@
           <p:nvPr/>
         </p:nvCxnSpPr>
         <p:spPr>
-          <a:xfrm flipH="1">
-            <a:off x="2276475" y="3603624"/>
-            <a:ext cx="14288" cy="555625"/>
+          <a:xfrm>
+            <a:off x="2276475" y="3604704"/>
+            <a:ext cx="0" cy="554545"/>
           </a:xfrm>
           <a:prstGeom prst="line">
             <a:avLst/>
@@ -20946,8 +21046,8 @@
         </p:nvCxnSpPr>
         <p:spPr>
           <a:xfrm>
-            <a:off x="7451725" y="3610370"/>
-            <a:ext cx="0" cy="550467"/>
+            <a:off x="7450525" y="3610370"/>
+            <a:ext cx="1200" cy="550467"/>
           </a:xfrm>
           <a:prstGeom prst="line">
             <a:avLst/>
@@ -21409,8 +21509,8 @@
         </p:nvSpPr>
         <p:spPr>
           <a:xfrm>
-            <a:off x="9723243" y="471768"/>
-            <a:ext cx="952500" cy="635000"/>
+            <a:off x="9679801" y="527050"/>
+            <a:ext cx="952500" cy="714881"/>
           </a:xfrm>
           <a:prstGeom prst="roundRect">
             <a:avLst/>
@@ -21445,6 +21545,13 @@
             <a:pPr algn="ctr"/>
             <a:r>
               <a:rPr lang="en-US" sz="1400" dirty="0"/>
+              <a:t>Used by</a:t>
+            </a:r>
+          </a:p>
+          <a:p>
+            <a:pPr algn="ctr"/>
+            <a:r>
+              <a:rPr lang="en-US" sz="1400" dirty="0"/>
               <a:t>Initiator Node</a:t>
             </a:r>
             <a:endParaRPr lang="nl-NL" sz="1400" dirty="0"/>
@@ -21465,8 +21572,8 @@
         </p:nvSpPr>
         <p:spPr>
           <a:xfrm>
-            <a:off x="10782300" y="471768"/>
-            <a:ext cx="952500" cy="635000"/>
+            <a:off x="10738858" y="527050"/>
+            <a:ext cx="952500" cy="714881"/>
           </a:xfrm>
           <a:prstGeom prst="roundRect">
             <a:avLst/>
@@ -21497,6 +21604,13 @@
         <p:txBody>
           <a:bodyPr lIns="0" tIns="0" rIns="0" bIns="0" rtlCol="0" anchor="ctr"/>
           <a:lstStyle/>
+          <a:p>
+            <a:pPr algn="ctr"/>
+            <a:r>
+              <a:rPr lang="en-US" sz="1400" dirty="0"/>
+              <a:t>Used by</a:t>
+            </a:r>
+          </a:p>
           <a:p>
             <a:pPr algn="ctr"/>
             <a:r>
@@ -23095,13 +23209,13 @@
   <p:clrMapOvr>
     <a:masterClrMapping/>
   </p:clrMapOvr>
-  <mc:AlternateContent xmlns:mc="http://schemas.openxmlformats.org/markup-compatibility/2006">
-    <mc:Choice xmlns:p14="http://schemas.microsoft.com/office/powerpoint/2010/main" Requires="p14">
+  <mc:AlternateContent xmlns:mc="http://schemas.openxmlformats.org/markup-compatibility/2006" xmlns:p14="http://schemas.microsoft.com/office/powerpoint/2010/main">
+    <mc:Choice Requires="p14">
       <p:transition spd="med" p14:dur="700">
         <p:fade/>
       </p:transition>
     </mc:Choice>
-    <mc:Fallback>
+    <mc:Fallback xmlns="">
       <p:transition spd="med">
         <p:fade/>
       </p:transition>

</xml_diff>